<commit_message>
Enhance font sizing and text fitting logic in pipeline
- Updated font size estimation to consider text content and bounding box dimensions.
- Introduced functions to classify text scripts (CJK, Latin, Numeric) for better font sizing accuracy.
- Added debug reporting for text fitting metrics to assist in analyzing OCR results.
- Modified the `add_text_block` function to disable auto-sizing for text frames.
- Updated tests to cover new font sizing logic and ensure correctness of text fitting metrics.
</commit_message>
<xml_diff>
--- a/output.pptx
+++ b/output.pptx
@@ -3132,13 +3132,13 @@
         </p:spPr>
         <p:txBody>
           <a:bodyPr wrap="square" lIns="0" rIns="0" tIns="0" bIns="0">
-            <a:normAutofit/>
-          </a:bodyPr>
-          <a:lstStyle/>
-          <a:p>
-            <a:pPr algn="l"/>
-            <a:r>
-              <a:rPr sz="1080" b="0" i="0">
+            <a:noAutofit/>
+          </a:bodyPr>
+          <a:lstStyle/>
+          <a:p>
+            <a:pPr algn="l"/>
+            <a:r>
+              <a:rPr sz="1350" b="0" i="0">
                 <a:solidFill>
                   <a:srgbClr val="1F1F1F"/>
                 </a:solidFill>
@@ -3166,13 +3166,13 @@
         </p:spPr>
         <p:txBody>
           <a:bodyPr wrap="square" lIns="0" rIns="0" tIns="0" bIns="0">
-            <a:normAutofit/>
-          </a:bodyPr>
-          <a:lstStyle/>
-          <a:p>
-            <a:pPr algn="l"/>
-            <a:r>
-              <a:rPr sz="900" b="0" i="0">
+            <a:noAutofit/>
+          </a:bodyPr>
+          <a:lstStyle/>
+          <a:p>
+            <a:pPr algn="l"/>
+            <a:r>
+              <a:rPr sz="1200" b="0" i="0">
                 <a:solidFill>
                   <a:srgbClr val="1F1F1F"/>
                 </a:solidFill>
@@ -3200,13 +3200,13 @@
         </p:spPr>
         <p:txBody>
           <a:bodyPr wrap="square" lIns="0" rIns="0" tIns="0" bIns="0">
-            <a:normAutofit/>
-          </a:bodyPr>
-          <a:lstStyle/>
-          <a:p>
-            <a:pPr algn="l"/>
-            <a:r>
-              <a:rPr sz="1116" b="0" i="0">
+            <a:noAutofit/>
+          </a:bodyPr>
+          <a:lstStyle/>
+          <a:p>
+            <a:pPr algn="l"/>
+            <a:r>
+              <a:rPr sz="1150" b="0" i="0">
                 <a:solidFill>
                   <a:srgbClr val="1F1F1F"/>
                 </a:solidFill>
@@ -3234,13 +3234,13 @@
         </p:spPr>
         <p:txBody>
           <a:bodyPr wrap="square" lIns="0" rIns="0" tIns="0" bIns="0">
-            <a:normAutofit/>
-          </a:bodyPr>
-          <a:lstStyle/>
-          <a:p>
-            <a:pPr algn="l"/>
-            <a:r>
-              <a:rPr sz="936" b="0" i="0">
+            <a:noAutofit/>
+          </a:bodyPr>
+          <a:lstStyle/>
+          <a:p>
+            <a:pPr algn="l"/>
+            <a:r>
+              <a:rPr sz="1200" b="0" i="0">
                 <a:solidFill>
                   <a:srgbClr val="1F1F1F"/>
                 </a:solidFill>
@@ -3268,13 +3268,13 @@
         </p:spPr>
         <p:txBody>
           <a:bodyPr wrap="square" lIns="0" rIns="0" tIns="0" bIns="0">
-            <a:normAutofit/>
-          </a:bodyPr>
-          <a:lstStyle/>
-          <a:p>
-            <a:pPr algn="l"/>
-            <a:r>
-              <a:rPr sz="971" b="0" i="0">
+            <a:noAutofit/>
+          </a:bodyPr>
+          <a:lstStyle/>
+          <a:p>
+            <a:pPr algn="l"/>
+            <a:r>
+              <a:rPr sz="1200" b="0" i="0">
                 <a:solidFill>
                   <a:srgbClr val="1F1F1F"/>
                 </a:solidFill>
@@ -3302,13 +3302,13 @@
         </p:spPr>
         <p:txBody>
           <a:bodyPr wrap="square" lIns="0" rIns="0" tIns="0" bIns="0">
-            <a:normAutofit/>
-          </a:bodyPr>
-          <a:lstStyle/>
-          <a:p>
-            <a:pPr algn="l"/>
-            <a:r>
-              <a:rPr sz="900" b="0" i="0">
+            <a:noAutofit/>
+          </a:bodyPr>
+          <a:lstStyle/>
+          <a:p>
+            <a:pPr algn="l"/>
+            <a:r>
+              <a:rPr sz="1200" b="0" i="0">
                 <a:solidFill>
                   <a:srgbClr val="E5E8EF"/>
                 </a:solidFill>
@@ -3336,13 +3336,13 @@
         </p:spPr>
         <p:txBody>
           <a:bodyPr wrap="square" lIns="0" rIns="0" tIns="0" bIns="0">
-            <a:normAutofit/>
-          </a:bodyPr>
-          <a:lstStyle/>
-          <a:p>
-            <a:pPr algn="l"/>
-            <a:r>
-              <a:rPr sz="900" b="0" i="0">
+            <a:noAutofit/>
+          </a:bodyPr>
+          <a:lstStyle/>
+          <a:p>
+            <a:pPr algn="l"/>
+            <a:r>
+              <a:rPr sz="1350" b="0" i="0">
                 <a:solidFill>
                   <a:srgbClr val="1F1F1F"/>
                 </a:solidFill>
@@ -3370,13 +3370,13 @@
         </p:spPr>
         <p:txBody>
           <a:bodyPr wrap="square" lIns="0" rIns="0" tIns="0" bIns="0">
-            <a:normAutofit/>
-          </a:bodyPr>
-          <a:lstStyle/>
-          <a:p>
-            <a:pPr algn="l"/>
-            <a:r>
-              <a:rPr sz="1188" b="0" i="0">
+            <a:noAutofit/>
+          </a:bodyPr>
+          <a:lstStyle/>
+          <a:p>
+            <a:pPr algn="l"/>
+            <a:r>
+              <a:rPr sz="1350" b="0" i="0">
                 <a:solidFill>
                   <a:srgbClr val="1F1F1F"/>
                 </a:solidFill>
@@ -3404,13 +3404,13 @@
         </p:spPr>
         <p:txBody>
           <a:bodyPr wrap="square" lIns="0" rIns="0" tIns="0" bIns="0">
-            <a:normAutofit/>
-          </a:bodyPr>
-          <a:lstStyle/>
-          <a:p>
-            <a:pPr algn="l"/>
-            <a:r>
-              <a:rPr sz="1080" b="0" i="0">
+            <a:noAutofit/>
+          </a:bodyPr>
+          <a:lstStyle/>
+          <a:p>
+            <a:pPr algn="l"/>
+            <a:r>
+              <a:rPr sz="1000" b="0" i="0">
                 <a:solidFill>
                   <a:srgbClr val="1F1F1F"/>
                 </a:solidFill>
@@ -3438,13 +3438,13 @@
         </p:spPr>
         <p:txBody>
           <a:bodyPr wrap="square" lIns="0" rIns="0" tIns="0" bIns="0">
-            <a:normAutofit/>
-          </a:bodyPr>
-          <a:lstStyle/>
-          <a:p>
-            <a:pPr algn="l"/>
-            <a:r>
-              <a:rPr sz="1080" b="0" i="0">
+            <a:noAutofit/>
+          </a:bodyPr>
+          <a:lstStyle/>
+          <a:p>
+            <a:pPr algn="l"/>
+            <a:r>
+              <a:rPr sz="1000" b="0" i="0">
                 <a:solidFill>
                   <a:srgbClr val="1F1F1F"/>
                 </a:solidFill>
@@ -3472,13 +3472,13 @@
         </p:spPr>
         <p:txBody>
           <a:bodyPr wrap="square" lIns="0" rIns="0" tIns="0" bIns="0">
-            <a:normAutofit/>
-          </a:bodyPr>
-          <a:lstStyle/>
-          <a:p>
-            <a:pPr algn="l"/>
-            <a:r>
-              <a:rPr sz="900" b="0" i="0">
+            <a:noAutofit/>
+          </a:bodyPr>
+          <a:lstStyle/>
+          <a:p>
+            <a:pPr algn="l"/>
+            <a:r>
+              <a:rPr sz="1000" b="0" i="0">
                 <a:solidFill>
                   <a:srgbClr val="1F1F1F"/>
                 </a:solidFill>
@@ -3506,13 +3506,13 @@
         </p:spPr>
         <p:txBody>
           <a:bodyPr wrap="square" lIns="0" rIns="0" tIns="0" bIns="0">
-            <a:normAutofit/>
-          </a:bodyPr>
-          <a:lstStyle/>
-          <a:p>
-            <a:pPr algn="l"/>
-            <a:r>
-              <a:rPr sz="1080" b="0" i="0">
+            <a:noAutofit/>
+          </a:bodyPr>
+          <a:lstStyle/>
+          <a:p>
+            <a:pPr algn="l"/>
+            <a:r>
+              <a:rPr sz="1100" b="0" i="0">
                 <a:solidFill>
                   <a:srgbClr val="1F1F1F"/>
                 </a:solidFill>
@@ -3540,13 +3540,13 @@
         </p:spPr>
         <p:txBody>
           <a:bodyPr wrap="square" lIns="0" rIns="0" tIns="0" bIns="0">
-            <a:normAutofit/>
-          </a:bodyPr>
-          <a:lstStyle/>
-          <a:p>
-            <a:pPr algn="l"/>
-            <a:r>
-              <a:rPr sz="900" b="0" i="0">
+            <a:noAutofit/>
+          </a:bodyPr>
+          <a:lstStyle/>
+          <a:p>
+            <a:pPr algn="l"/>
+            <a:r>
+              <a:rPr sz="1400" b="0" i="0">
                 <a:solidFill>
                   <a:srgbClr val="1F1F1F"/>
                 </a:solidFill>
@@ -3574,13 +3574,13 @@
         </p:spPr>
         <p:txBody>
           <a:bodyPr wrap="square" lIns="0" rIns="0" tIns="0" bIns="0">
-            <a:normAutofit/>
-          </a:bodyPr>
-          <a:lstStyle/>
-          <a:p>
-            <a:pPr algn="l"/>
-            <a:r>
-              <a:rPr sz="1080" b="0" i="0">
+            <a:noAutofit/>
+          </a:bodyPr>
+          <a:lstStyle/>
+          <a:p>
+            <a:pPr algn="l"/>
+            <a:r>
+              <a:rPr sz="1000" b="0" i="0">
                 <a:solidFill>
                   <a:srgbClr val="C9CDD3"/>
                 </a:solidFill>
@@ -3608,13 +3608,13 @@
         </p:spPr>
         <p:txBody>
           <a:bodyPr wrap="square" lIns="0" rIns="0" tIns="0" bIns="0">
-            <a:normAutofit/>
-          </a:bodyPr>
-          <a:lstStyle/>
-          <a:p>
-            <a:pPr algn="l"/>
-            <a:r>
-              <a:rPr sz="971" b="0" i="0">
+            <a:noAutofit/>
+          </a:bodyPr>
+          <a:lstStyle/>
+          <a:p>
+            <a:pPr algn="l"/>
+            <a:r>
+              <a:rPr sz="1000" b="0" i="0">
                 <a:solidFill>
                   <a:srgbClr val="1F1F1F"/>
                 </a:solidFill>
@@ -3642,13 +3642,13 @@
         </p:spPr>
         <p:txBody>
           <a:bodyPr wrap="square" lIns="0" rIns="0" tIns="0" bIns="0">
-            <a:normAutofit/>
-          </a:bodyPr>
-          <a:lstStyle/>
-          <a:p>
-            <a:pPr algn="l"/>
-            <a:r>
-              <a:rPr sz="900" b="0" i="0">
+            <a:noAutofit/>
+          </a:bodyPr>
+          <a:lstStyle/>
+          <a:p>
+            <a:pPr algn="l"/>
+            <a:r>
+              <a:rPr sz="1400" b="0" i="0">
                 <a:solidFill>
                   <a:srgbClr val="1F1F1F"/>
                 </a:solidFill>
@@ -3676,13 +3676,13 @@
         </p:spPr>
         <p:txBody>
           <a:bodyPr wrap="square" lIns="0" rIns="0" tIns="0" bIns="0">
-            <a:normAutofit/>
-          </a:bodyPr>
-          <a:lstStyle/>
-          <a:p>
-            <a:pPr algn="l"/>
-            <a:r>
-              <a:rPr sz="756" b="0" i="0">
+            <a:noAutofit/>
+          </a:bodyPr>
+          <a:lstStyle/>
+          <a:p>
+            <a:pPr algn="l"/>
+            <a:r>
+              <a:rPr sz="1150" b="0" i="0">
                 <a:solidFill>
                   <a:srgbClr val="E4E9EF"/>
                 </a:solidFill>
@@ -3710,13 +3710,13 @@
         </p:spPr>
         <p:txBody>
           <a:bodyPr wrap="square" lIns="0" rIns="0" tIns="0" bIns="0">
-            <a:normAutofit/>
-          </a:bodyPr>
-          <a:lstStyle/>
-          <a:p>
-            <a:pPr algn="l"/>
-            <a:r>
-              <a:rPr sz="648" b="0" i="0">
+            <a:noAutofit/>
+          </a:bodyPr>
+          <a:lstStyle/>
+          <a:p>
+            <a:pPr algn="l"/>
+            <a:r>
+              <a:rPr sz="1050" b="0" i="0">
                 <a:solidFill>
                   <a:srgbClr val="1F1F1F"/>
                 </a:solidFill>
@@ -3744,13 +3744,13 @@
         </p:spPr>
         <p:txBody>
           <a:bodyPr wrap="square" lIns="0" rIns="0" tIns="0" bIns="0">
-            <a:normAutofit/>
-          </a:bodyPr>
-          <a:lstStyle/>
-          <a:p>
-            <a:pPr algn="l"/>
-            <a:r>
-              <a:rPr sz="864" b="0" i="0">
+            <a:noAutofit/>
+          </a:bodyPr>
+          <a:lstStyle/>
+          <a:p>
+            <a:pPr algn="l"/>
+            <a:r>
+              <a:rPr sz="1100" b="0" i="0">
                 <a:solidFill>
                   <a:srgbClr val="1F1F1F"/>
                 </a:solidFill>
@@ -3778,13 +3778,13 @@
         </p:spPr>
         <p:txBody>
           <a:bodyPr wrap="square" lIns="0" rIns="0" tIns="0" bIns="0">
-            <a:normAutofit/>
-          </a:bodyPr>
-          <a:lstStyle/>
-          <a:p>
-            <a:pPr algn="l"/>
-            <a:r>
-              <a:rPr sz="1080" b="0" i="0">
+            <a:noAutofit/>
+          </a:bodyPr>
+          <a:lstStyle/>
+          <a:p>
+            <a:pPr algn="l"/>
+            <a:r>
+              <a:rPr sz="1000" b="0" i="0">
                 <a:solidFill>
                   <a:srgbClr val="C7CCD1"/>
                 </a:solidFill>
@@ -3812,13 +3812,13 @@
         </p:spPr>
         <p:txBody>
           <a:bodyPr wrap="square" lIns="0" rIns="0" tIns="0" bIns="0">
-            <a:normAutofit/>
-          </a:bodyPr>
-          <a:lstStyle/>
-          <a:p>
-            <a:pPr algn="l"/>
-            <a:r>
-              <a:rPr sz="1080" b="0" i="0">
+            <a:noAutofit/>
+          </a:bodyPr>
+          <a:lstStyle/>
+          <a:p>
+            <a:pPr algn="l"/>
+            <a:r>
+              <a:rPr sz="1000" b="0" i="0">
                 <a:solidFill>
                   <a:srgbClr val="1F1F1F"/>
                 </a:solidFill>
@@ -3846,13 +3846,13 @@
         </p:spPr>
         <p:txBody>
           <a:bodyPr wrap="square" lIns="0" rIns="0" tIns="0" bIns="0">
-            <a:normAutofit/>
-          </a:bodyPr>
-          <a:lstStyle/>
-          <a:p>
-            <a:pPr algn="l"/>
-            <a:r>
-              <a:rPr sz="792" b="0" i="0">
+            <a:noAutofit/>
+          </a:bodyPr>
+          <a:lstStyle/>
+          <a:p>
+            <a:pPr algn="l"/>
+            <a:r>
+              <a:rPr sz="1250" b="0" i="0">
                 <a:solidFill>
                   <a:srgbClr val="1F1F1F"/>
                 </a:solidFill>
@@ -3880,13 +3880,13 @@
         </p:spPr>
         <p:txBody>
           <a:bodyPr wrap="square" lIns="0" rIns="0" tIns="0" bIns="0">
-            <a:normAutofit/>
-          </a:bodyPr>
-          <a:lstStyle/>
-          <a:p>
-            <a:pPr algn="l"/>
-            <a:r>
-              <a:rPr sz="1116" b="0" i="0">
+            <a:noAutofit/>
+          </a:bodyPr>
+          <a:lstStyle/>
+          <a:p>
+            <a:pPr algn="l"/>
+            <a:r>
+              <a:rPr sz="1350" b="0" i="0">
                 <a:solidFill>
                   <a:srgbClr val="1F1F1F"/>
                 </a:solidFill>
@@ -3914,13 +3914,13 @@
         </p:spPr>
         <p:txBody>
           <a:bodyPr wrap="square" lIns="0" rIns="0" tIns="0" bIns="0">
-            <a:normAutofit/>
-          </a:bodyPr>
-          <a:lstStyle/>
-          <a:p>
-            <a:pPr algn="l"/>
-            <a:r>
-              <a:rPr sz="827" b="0" i="0">
+            <a:noAutofit/>
+          </a:bodyPr>
+          <a:lstStyle/>
+          <a:p>
+            <a:pPr algn="l"/>
+            <a:r>
+              <a:rPr sz="1300" b="0" i="0">
                 <a:solidFill>
                   <a:srgbClr val="E9E8DE"/>
                 </a:solidFill>
@@ -3948,13 +3948,13 @@
         </p:spPr>
         <p:txBody>
           <a:bodyPr wrap="square" lIns="0" rIns="0" tIns="0" bIns="0">
-            <a:normAutofit/>
-          </a:bodyPr>
-          <a:lstStyle/>
-          <a:p>
-            <a:pPr algn="l"/>
-            <a:r>
-              <a:rPr sz="971" b="0" i="0">
+            <a:noAutofit/>
+          </a:bodyPr>
+          <a:lstStyle/>
+          <a:p>
+            <a:pPr algn="l"/>
+            <a:r>
+              <a:rPr sz="1400" b="0" i="0">
                 <a:solidFill>
                   <a:srgbClr val="E4E8EF"/>
                 </a:solidFill>
@@ -3982,13 +3982,13 @@
         </p:spPr>
         <p:txBody>
           <a:bodyPr wrap="square" lIns="0" rIns="0" tIns="0" bIns="0">
-            <a:normAutofit/>
-          </a:bodyPr>
-          <a:lstStyle/>
-          <a:p>
-            <a:pPr algn="l"/>
-            <a:r>
-              <a:rPr sz="900" b="0" i="0">
+            <a:noAutofit/>
+          </a:bodyPr>
+          <a:lstStyle/>
+          <a:p>
+            <a:pPr algn="l"/>
+            <a:r>
+              <a:rPr sz="1000" b="0" i="0">
                 <a:solidFill>
                   <a:srgbClr val="1F1F1F"/>
                 </a:solidFill>
@@ -4016,13 +4016,13 @@
         </p:spPr>
         <p:txBody>
           <a:bodyPr wrap="square" lIns="0" rIns="0" tIns="0" bIns="0">
-            <a:normAutofit/>
-          </a:bodyPr>
-          <a:lstStyle/>
-          <a:p>
-            <a:pPr algn="l"/>
-            <a:r>
-              <a:rPr sz="1080" b="0" i="0">
+            <a:noAutofit/>
+          </a:bodyPr>
+          <a:lstStyle/>
+          <a:p>
+            <a:pPr algn="l"/>
+            <a:r>
+              <a:rPr sz="1000" b="0" i="0">
                 <a:solidFill>
                   <a:srgbClr val="1F1F1F"/>
                 </a:solidFill>
@@ -4050,13 +4050,13 @@
         </p:spPr>
         <p:txBody>
           <a:bodyPr wrap="square" lIns="0" rIns="0" tIns="0" bIns="0">
-            <a:normAutofit/>
-          </a:bodyPr>
-          <a:lstStyle/>
-          <a:p>
-            <a:pPr algn="l"/>
-            <a:r>
-              <a:rPr sz="864" b="0" i="0">
+            <a:noAutofit/>
+          </a:bodyPr>
+          <a:lstStyle/>
+          <a:p>
+            <a:pPr algn="l"/>
+            <a:r>
+              <a:rPr sz="1300" b="0" i="0">
                 <a:solidFill>
                   <a:srgbClr val="1F1F1F"/>
                 </a:solidFill>
@@ -4084,13 +4084,13 @@
         </p:spPr>
         <p:txBody>
           <a:bodyPr wrap="square" lIns="0" rIns="0" tIns="0" bIns="0">
-            <a:normAutofit/>
-          </a:bodyPr>
-          <a:lstStyle/>
-          <a:p>
-            <a:pPr algn="l"/>
-            <a:r>
-              <a:rPr sz="648" b="0" i="0">
+            <a:noAutofit/>
+          </a:bodyPr>
+          <a:lstStyle/>
+          <a:p>
+            <a:pPr algn="l"/>
+            <a:r>
+              <a:rPr sz="1000" b="0" i="0">
                 <a:solidFill>
                   <a:srgbClr val="DDE2E7"/>
                 </a:solidFill>
@@ -4118,13 +4118,13 @@
         </p:spPr>
         <p:txBody>
           <a:bodyPr wrap="square" lIns="0" rIns="0" tIns="0" bIns="0">
-            <a:normAutofit/>
-          </a:bodyPr>
-          <a:lstStyle/>
-          <a:p>
-            <a:pPr algn="l"/>
-            <a:r>
-              <a:rPr sz="600" b="0" i="0">
+            <a:noAutofit/>
+          </a:bodyPr>
+          <a:lstStyle/>
+          <a:p>
+            <a:pPr algn="l"/>
+            <a:r>
+              <a:rPr sz="900" b="0" i="0">
                 <a:solidFill>
                   <a:srgbClr val="1F1F1F"/>
                 </a:solidFill>
@@ -4152,13 +4152,13 @@
         </p:spPr>
         <p:txBody>
           <a:bodyPr wrap="square" lIns="0" rIns="0" tIns="0" bIns="0">
-            <a:normAutofit/>
-          </a:bodyPr>
-          <a:lstStyle/>
-          <a:p>
-            <a:pPr algn="l"/>
-            <a:r>
-              <a:rPr sz="1600" b="0" i="0">
+            <a:noAutofit/>
+          </a:bodyPr>
+          <a:lstStyle/>
+          <a:p>
+            <a:pPr algn="l"/>
+            <a:r>
+              <a:rPr sz="4800" b="0" i="0">
                 <a:solidFill>
                   <a:srgbClr val="B1B6BB"/>
                 </a:solidFill>
@@ -4186,13 +4186,13 @@
         </p:spPr>
         <p:txBody>
           <a:bodyPr wrap="square" lIns="0" rIns="0" tIns="0" bIns="0">
-            <a:normAutofit/>
-          </a:bodyPr>
-          <a:lstStyle/>
-          <a:p>
-            <a:pPr algn="l"/>
-            <a:r>
-              <a:rPr sz="1600" b="0" i="0">
+            <a:noAutofit/>
+          </a:bodyPr>
+          <a:lstStyle/>
+          <a:p>
+            <a:pPr algn="l"/>
+            <a:r>
+              <a:rPr sz="3700" b="0" i="0">
                 <a:solidFill>
                   <a:srgbClr val="C2C6CC"/>
                 </a:solidFill>
@@ -4220,13 +4220,13 @@
         </p:spPr>
         <p:txBody>
           <a:bodyPr wrap="square" lIns="0" rIns="0" tIns="0" bIns="0">
-            <a:normAutofit/>
-          </a:bodyPr>
-          <a:lstStyle/>
-          <a:p>
-            <a:pPr algn="l"/>
-            <a:r>
-              <a:rPr sz="1116" b="0" i="0">
+            <a:noAutofit/>
+          </a:bodyPr>
+          <a:lstStyle/>
+          <a:p>
+            <a:pPr algn="l"/>
+            <a:r>
+              <a:rPr sz="1350" b="0" i="0">
                 <a:solidFill>
                   <a:srgbClr val="ACB0B7"/>
                 </a:solidFill>
@@ -4296,13 +4296,13 @@
         </p:spPr>
         <p:txBody>
           <a:bodyPr wrap="square" lIns="0" rIns="0" tIns="0" bIns="0">
-            <a:normAutofit/>
-          </a:bodyPr>
-          <a:lstStyle/>
-          <a:p>
-            <a:pPr algn="l"/>
-            <a:r>
-              <a:rPr sz="1600" b="0" i="0">
+            <a:noAutofit/>
+          </a:bodyPr>
+          <a:lstStyle/>
+          <a:p>
+            <a:pPr algn="l"/>
+            <a:r>
+              <a:rPr sz="4700" b="0" i="0">
                 <a:solidFill>
                   <a:srgbClr val="1F1F1F"/>
                 </a:solidFill>
@@ -4330,13 +4330,13 @@
         </p:spPr>
         <p:txBody>
           <a:bodyPr wrap="square" lIns="0" rIns="0" tIns="0" bIns="0">
-            <a:normAutofit/>
-          </a:bodyPr>
-          <a:lstStyle/>
-          <a:p>
-            <a:pPr algn="l"/>
-            <a:r>
-              <a:rPr sz="1600" b="0" i="0">
+            <a:noAutofit/>
+          </a:bodyPr>
+          <a:lstStyle/>
+          <a:p>
+            <a:pPr algn="l"/>
+            <a:r>
+              <a:rPr sz="2600" b="0" i="0">
                 <a:solidFill>
                   <a:srgbClr val="1F1F1F"/>
                 </a:solidFill>
@@ -4364,13 +4364,13 @@
         </p:spPr>
         <p:txBody>
           <a:bodyPr wrap="square" lIns="0" rIns="0" tIns="0" bIns="0">
-            <a:normAutofit/>
-          </a:bodyPr>
-          <a:lstStyle/>
-          <a:p>
-            <a:pPr algn="l"/>
-            <a:r>
-              <a:rPr sz="936" b="0" i="0">
+            <a:noAutofit/>
+          </a:bodyPr>
+          <a:lstStyle/>
+          <a:p>
+            <a:pPr algn="l"/>
+            <a:r>
+              <a:rPr sz="1200" b="0" i="0">
                 <a:solidFill>
                   <a:srgbClr val="1F1F1F"/>
                 </a:solidFill>
@@ -4398,13 +4398,13 @@
         </p:spPr>
         <p:txBody>
           <a:bodyPr wrap="square" lIns="0" rIns="0" tIns="0" bIns="0">
-            <a:normAutofit/>
-          </a:bodyPr>
-          <a:lstStyle/>
-          <a:p>
-            <a:pPr algn="l"/>
-            <a:r>
-              <a:rPr sz="971" b="0" i="0">
+            <a:noAutofit/>
+          </a:bodyPr>
+          <a:lstStyle/>
+          <a:p>
+            <a:pPr algn="l"/>
+            <a:r>
+              <a:rPr sz="1250" b="0" i="0">
                 <a:solidFill>
                   <a:srgbClr val="DDE1E7"/>
                 </a:solidFill>
@@ -4432,13 +4432,13 @@
         </p:spPr>
         <p:txBody>
           <a:bodyPr wrap="square" lIns="0" rIns="0" tIns="0" bIns="0">
-            <a:normAutofit/>
-          </a:bodyPr>
-          <a:lstStyle/>
-          <a:p>
-            <a:pPr algn="l"/>
-            <a:r>
-              <a:rPr sz="1600" b="0" i="0">
+            <a:noAutofit/>
+          </a:bodyPr>
+          <a:lstStyle/>
+          <a:p>
+            <a:pPr algn="l"/>
+            <a:r>
+              <a:rPr sz="2600" b="0" i="0">
                 <a:solidFill>
                   <a:srgbClr val="BCC4CB"/>
                 </a:solidFill>
@@ -4466,13 +4466,13 @@
         </p:spPr>
         <p:txBody>
           <a:bodyPr wrap="square" lIns="0" rIns="0" tIns="0" bIns="0">
-            <a:normAutofit/>
-          </a:bodyPr>
-          <a:lstStyle/>
-          <a:p>
-            <a:pPr algn="l"/>
-            <a:r>
-              <a:rPr sz="1600" b="0" i="0">
+            <a:noAutofit/>
+          </a:bodyPr>
+          <a:lstStyle/>
+          <a:p>
+            <a:pPr algn="l"/>
+            <a:r>
+              <a:rPr sz="3300" b="0" i="0">
                 <a:solidFill>
                   <a:srgbClr val="FFFFFF"/>
                 </a:solidFill>
@@ -4500,13 +4500,13 @@
         </p:spPr>
         <p:txBody>
           <a:bodyPr wrap="square" lIns="0" rIns="0" tIns="0" bIns="0">
-            <a:normAutofit/>
-          </a:bodyPr>
-          <a:lstStyle/>
-          <a:p>
-            <a:pPr algn="l"/>
-            <a:r>
-              <a:rPr sz="1600" b="0" i="0">
+            <a:noAutofit/>
+          </a:bodyPr>
+          <a:lstStyle/>
+          <a:p>
+            <a:pPr algn="l"/>
+            <a:r>
+              <a:rPr sz="3150" b="0" i="0">
                 <a:solidFill>
                   <a:srgbClr val="8693A3"/>
                 </a:solidFill>
@@ -4534,13 +4534,13 @@
         </p:spPr>
         <p:txBody>
           <a:bodyPr wrap="square" lIns="0" rIns="0" tIns="0" bIns="0">
-            <a:normAutofit/>
-          </a:bodyPr>
-          <a:lstStyle/>
-          <a:p>
-            <a:pPr algn="l"/>
-            <a:r>
-              <a:rPr sz="1600" b="0" i="0">
+            <a:noAutofit/>
+          </a:bodyPr>
+          <a:lstStyle/>
+          <a:p>
+            <a:pPr algn="l"/>
+            <a:r>
+              <a:rPr sz="2450" b="0" i="0">
                 <a:solidFill>
                   <a:srgbClr val="B7B1A3"/>
                 </a:solidFill>
@@ -4568,13 +4568,13 @@
         </p:spPr>
         <p:txBody>
           <a:bodyPr wrap="square" lIns="0" rIns="0" tIns="0" bIns="0">
-            <a:normAutofit/>
-          </a:bodyPr>
-          <a:lstStyle/>
-          <a:p>
-            <a:pPr algn="l"/>
-            <a:r>
-              <a:rPr sz="1600" b="0" i="0">
+            <a:noAutofit/>
+          </a:bodyPr>
+          <a:lstStyle/>
+          <a:p>
+            <a:pPr algn="l"/>
+            <a:r>
+              <a:rPr sz="2350" b="0" i="0">
                 <a:solidFill>
                   <a:srgbClr val="1F1F1F"/>
                 </a:solidFill>
@@ -4602,13 +4602,13 @@
         </p:spPr>
         <p:txBody>
           <a:bodyPr wrap="square" lIns="0" rIns="0" tIns="0" bIns="0">
-            <a:normAutofit/>
-          </a:bodyPr>
-          <a:lstStyle/>
-          <a:p>
-            <a:pPr algn="l"/>
-            <a:r>
-              <a:rPr sz="1600" b="0" i="0">
+            <a:noAutofit/>
+          </a:bodyPr>
+          <a:lstStyle/>
+          <a:p>
+            <a:pPr algn="l"/>
+            <a:r>
+              <a:rPr sz="2550" b="0" i="0">
                 <a:solidFill>
                   <a:srgbClr val="1F1F1F"/>
                 </a:solidFill>
@@ -4636,13 +4636,13 @@
         </p:spPr>
         <p:txBody>
           <a:bodyPr wrap="square" lIns="0" rIns="0" tIns="0" bIns="0">
-            <a:normAutofit/>
-          </a:bodyPr>
-          <a:lstStyle/>
-          <a:p>
-            <a:pPr algn="l"/>
-            <a:r>
-              <a:rPr sz="1600" b="0" i="0">
+            <a:noAutofit/>
+          </a:bodyPr>
+          <a:lstStyle/>
+          <a:p>
+            <a:pPr algn="l"/>
+            <a:r>
+              <a:rPr sz="2450" b="0" i="0">
                 <a:solidFill>
                   <a:srgbClr val="1F1F1F"/>
                 </a:solidFill>
@@ -4670,13 +4670,13 @@
         </p:spPr>
         <p:txBody>
           <a:bodyPr wrap="square" lIns="0" rIns="0" tIns="0" bIns="0">
-            <a:normAutofit/>
-          </a:bodyPr>
-          <a:lstStyle/>
-          <a:p>
-            <a:pPr algn="l"/>
-            <a:r>
-              <a:rPr sz="1600" b="0" i="0">
+            <a:noAutofit/>
+          </a:bodyPr>
+          <a:lstStyle/>
+          <a:p>
+            <a:pPr algn="l"/>
+            <a:r>
+              <a:rPr sz="2000" b="0" i="0">
                 <a:solidFill>
                   <a:srgbClr val="D7B6B8"/>
                 </a:solidFill>
@@ -4704,13 +4704,13 @@
         </p:spPr>
         <p:txBody>
           <a:bodyPr wrap="square" lIns="0" rIns="0" tIns="0" bIns="0">
-            <a:normAutofit/>
-          </a:bodyPr>
-          <a:lstStyle/>
-          <a:p>
-            <a:pPr algn="l"/>
-            <a:r>
-              <a:rPr sz="1600" b="0" i="0">
+            <a:noAutofit/>
+          </a:bodyPr>
+          <a:lstStyle/>
+          <a:p>
+            <a:pPr algn="l"/>
+            <a:r>
+              <a:rPr sz="2300" b="0" i="0">
                 <a:solidFill>
                   <a:srgbClr val="1F1F1F"/>
                 </a:solidFill>
@@ -4738,13 +4738,13 @@
         </p:spPr>
         <p:txBody>
           <a:bodyPr wrap="square" lIns="0" rIns="0" tIns="0" bIns="0">
-            <a:normAutofit/>
-          </a:bodyPr>
-          <a:lstStyle/>
-          <a:p>
-            <a:pPr algn="l"/>
-            <a:r>
-              <a:rPr sz="1332" b="0" i="0">
+            <a:noAutofit/>
+          </a:bodyPr>
+          <a:lstStyle/>
+          <a:p>
+            <a:pPr algn="l"/>
+            <a:r>
+              <a:rPr sz="1350" b="0" i="0">
                 <a:solidFill>
                   <a:srgbClr val="1F1F1F"/>
                 </a:solidFill>
@@ -4772,13 +4772,13 @@
         </p:spPr>
         <p:txBody>
           <a:bodyPr wrap="square" lIns="0" rIns="0" tIns="0" bIns="0">
-            <a:normAutofit/>
-          </a:bodyPr>
-          <a:lstStyle/>
-          <a:p>
-            <a:pPr algn="l"/>
-            <a:r>
-              <a:rPr sz="1600" b="0" i="0">
+            <a:noAutofit/>
+          </a:bodyPr>
+          <a:lstStyle/>
+          <a:p>
+            <a:pPr algn="l"/>
+            <a:r>
+              <a:rPr sz="2400" b="0" i="0">
                 <a:solidFill>
                   <a:srgbClr val="1F1F1F"/>
                 </a:solidFill>
@@ -4806,13 +4806,13 @@
         </p:spPr>
         <p:txBody>
           <a:bodyPr wrap="square" lIns="0" rIns="0" tIns="0" bIns="0">
-            <a:normAutofit/>
-          </a:bodyPr>
-          <a:lstStyle/>
-          <a:p>
-            <a:pPr algn="l"/>
-            <a:r>
-              <a:rPr sz="1600" b="0" i="0">
+            <a:noAutofit/>
+          </a:bodyPr>
+          <a:lstStyle/>
+          <a:p>
+            <a:pPr algn="l"/>
+            <a:r>
+              <a:rPr sz="2350" b="0" i="0">
                 <a:solidFill>
                   <a:srgbClr val="1F1F1F"/>
                 </a:solidFill>
@@ -4840,13 +4840,13 @@
         </p:spPr>
         <p:txBody>
           <a:bodyPr wrap="square" lIns="0" rIns="0" tIns="0" bIns="0">
-            <a:normAutofit/>
-          </a:bodyPr>
-          <a:lstStyle/>
-          <a:p>
-            <a:pPr algn="l"/>
-            <a:r>
-              <a:rPr sz="1600" b="0" i="0">
+            <a:noAutofit/>
+          </a:bodyPr>
+          <a:lstStyle/>
+          <a:p>
+            <a:pPr algn="l"/>
+            <a:r>
+              <a:rPr sz="2300" b="0" i="0">
                 <a:solidFill>
                   <a:srgbClr val="1F1F1F"/>
                 </a:solidFill>
@@ -4874,13 +4874,13 @@
         </p:spPr>
         <p:txBody>
           <a:bodyPr wrap="square" lIns="0" rIns="0" tIns="0" bIns="0">
-            <a:normAutofit/>
-          </a:bodyPr>
-          <a:lstStyle/>
-          <a:p>
-            <a:pPr algn="l"/>
-            <a:r>
-              <a:rPr sz="1600" b="0" i="0">
+            <a:noAutofit/>
+          </a:bodyPr>
+          <a:lstStyle/>
+          <a:p>
+            <a:pPr algn="l"/>
+            <a:r>
+              <a:rPr sz="2350" b="0" i="0">
                 <a:solidFill>
                   <a:srgbClr val="1F1F1F"/>
                 </a:solidFill>
@@ -4908,13 +4908,13 @@
         </p:spPr>
         <p:txBody>
           <a:bodyPr wrap="square" lIns="0" rIns="0" tIns="0" bIns="0">
-            <a:normAutofit/>
-          </a:bodyPr>
-          <a:lstStyle/>
-          <a:p>
-            <a:pPr algn="l"/>
-            <a:r>
-              <a:rPr sz="1600" b="0" i="0">
+            <a:noAutofit/>
+          </a:bodyPr>
+          <a:lstStyle/>
+          <a:p>
+            <a:pPr algn="l"/>
+            <a:r>
+              <a:rPr sz="2450" b="0" i="0">
                 <a:solidFill>
                   <a:srgbClr val="A39F92"/>
                 </a:solidFill>
@@ -4942,13 +4942,13 @@
         </p:spPr>
         <p:txBody>
           <a:bodyPr wrap="square" lIns="0" rIns="0" tIns="0" bIns="0">
-            <a:normAutofit/>
-          </a:bodyPr>
-          <a:lstStyle/>
-          <a:p>
-            <a:pPr algn="l"/>
-            <a:r>
-              <a:rPr sz="1600" b="0" i="0">
+            <a:noAutofit/>
+          </a:bodyPr>
+          <a:lstStyle/>
+          <a:p>
+            <a:pPr algn="l"/>
+            <a:r>
+              <a:rPr sz="2400" b="0" i="0">
                 <a:solidFill>
                   <a:srgbClr val="1F1F1F"/>
                 </a:solidFill>
@@ -4976,13 +4976,13 @@
         </p:spPr>
         <p:txBody>
           <a:bodyPr wrap="square" lIns="0" rIns="0" tIns="0" bIns="0">
-            <a:normAutofit/>
-          </a:bodyPr>
-          <a:lstStyle/>
-          <a:p>
-            <a:pPr algn="l"/>
-            <a:r>
-              <a:rPr sz="1600" b="0" i="0">
+            <a:noAutofit/>
+          </a:bodyPr>
+          <a:lstStyle/>
+          <a:p>
+            <a:pPr algn="l"/>
+            <a:r>
+              <a:rPr sz="2150" b="0" i="0">
                 <a:solidFill>
                   <a:srgbClr val="B8B2A3"/>
                 </a:solidFill>
@@ -5010,13 +5010,13 @@
         </p:spPr>
         <p:txBody>
           <a:bodyPr wrap="square" lIns="0" rIns="0" tIns="0" bIns="0">
-            <a:normAutofit/>
-          </a:bodyPr>
-          <a:lstStyle/>
-          <a:p>
-            <a:pPr algn="l"/>
-            <a:r>
-              <a:rPr sz="1008" b="0" i="0">
+            <a:noAutofit/>
+          </a:bodyPr>
+          <a:lstStyle/>
+          <a:p>
+            <a:pPr algn="l"/>
+            <a:r>
+              <a:rPr sz="1350" b="0" i="0">
                 <a:solidFill>
                   <a:srgbClr val="A6ABB0"/>
                 </a:solidFill>
@@ -5086,13 +5086,13 @@
         </p:spPr>
         <p:txBody>
           <a:bodyPr wrap="square" lIns="0" rIns="0" tIns="0" bIns="0">
-            <a:normAutofit/>
-          </a:bodyPr>
-          <a:lstStyle/>
-          <a:p>
-            <a:pPr algn="l"/>
-            <a:r>
-              <a:rPr sz="1600" b="0" i="0">
+            <a:noAutofit/>
+          </a:bodyPr>
+          <a:lstStyle/>
+          <a:p>
+            <a:pPr algn="l"/>
+            <a:r>
+              <a:rPr sz="4750" b="0" i="0">
                 <a:solidFill>
                   <a:srgbClr val="1F1F1F"/>
                 </a:solidFill>
@@ -5120,13 +5120,13 @@
         </p:spPr>
         <p:txBody>
           <a:bodyPr wrap="square" lIns="0" rIns="0" tIns="0" bIns="0">
-            <a:normAutofit/>
-          </a:bodyPr>
-          <a:lstStyle/>
-          <a:p>
-            <a:pPr algn="l"/>
-            <a:r>
-              <a:rPr sz="1600" b="0" i="0">
+            <a:noAutofit/>
+          </a:bodyPr>
+          <a:lstStyle/>
+          <a:p>
+            <a:pPr algn="l"/>
+            <a:r>
+              <a:rPr sz="2950" b="0" i="0">
                 <a:solidFill>
                   <a:srgbClr val="1F1F1F"/>
                 </a:solidFill>
@@ -5154,13 +5154,13 @@
         </p:spPr>
         <p:txBody>
           <a:bodyPr wrap="square" lIns="0" rIns="0" tIns="0" bIns="0">
-            <a:normAutofit/>
-          </a:bodyPr>
-          <a:lstStyle/>
-          <a:p>
-            <a:pPr algn="l"/>
-            <a:r>
-              <a:rPr sz="1600" b="0" i="0">
+            <a:noAutofit/>
+          </a:bodyPr>
+          <a:lstStyle/>
+          <a:p>
+            <a:pPr algn="l"/>
+            <a:r>
+              <a:rPr sz="2850" b="0" i="0">
                 <a:solidFill>
                   <a:srgbClr val="1F1F1F"/>
                 </a:solidFill>
@@ -5188,13 +5188,13 @@
         </p:spPr>
         <p:txBody>
           <a:bodyPr wrap="square" lIns="0" rIns="0" tIns="0" bIns="0">
-            <a:normAutofit/>
-          </a:bodyPr>
-          <a:lstStyle/>
-          <a:p>
-            <a:pPr algn="l"/>
-            <a:r>
-              <a:rPr sz="1600" b="0" i="0">
+            <a:noAutofit/>
+          </a:bodyPr>
+          <a:lstStyle/>
+          <a:p>
+            <a:pPr algn="l"/>
+            <a:r>
+              <a:rPr sz="2950" b="0" i="0">
                 <a:solidFill>
                   <a:srgbClr val="1F1F1F"/>
                 </a:solidFill>
@@ -5222,13 +5222,13 @@
         </p:spPr>
         <p:txBody>
           <a:bodyPr wrap="square" lIns="0" rIns="0" tIns="0" bIns="0">
-            <a:normAutofit/>
-          </a:bodyPr>
-          <a:lstStyle/>
-          <a:p>
-            <a:pPr algn="l"/>
-            <a:r>
-              <a:rPr sz="1600" b="0" i="0">
+            <a:noAutofit/>
+          </a:bodyPr>
+          <a:lstStyle/>
+          <a:p>
+            <a:pPr algn="l"/>
+            <a:r>
+              <a:rPr sz="2650" b="0" i="0">
                 <a:solidFill>
                   <a:srgbClr val="1F1F1F"/>
                 </a:solidFill>
@@ -5256,13 +5256,13 @@
         </p:spPr>
         <p:txBody>
           <a:bodyPr wrap="square" lIns="0" rIns="0" tIns="0" bIns="0">
-            <a:normAutofit/>
-          </a:bodyPr>
-          <a:lstStyle/>
-          <a:p>
-            <a:pPr algn="l"/>
-            <a:r>
-              <a:rPr sz="1600" b="0" i="0">
+            <a:noAutofit/>
+          </a:bodyPr>
+          <a:lstStyle/>
+          <a:p>
+            <a:pPr algn="l"/>
+            <a:r>
+              <a:rPr sz="2800" b="0" i="0">
                 <a:solidFill>
                   <a:srgbClr val="1F1F1F"/>
                 </a:solidFill>
@@ -5290,13 +5290,13 @@
         </p:spPr>
         <p:txBody>
           <a:bodyPr wrap="square" lIns="0" rIns="0" tIns="0" bIns="0">
-            <a:normAutofit/>
-          </a:bodyPr>
-          <a:lstStyle/>
-          <a:p>
-            <a:pPr algn="l"/>
-            <a:r>
-              <a:rPr sz="1600" b="0" i="0">
+            <a:noAutofit/>
+          </a:bodyPr>
+          <a:lstStyle/>
+          <a:p>
+            <a:pPr algn="l"/>
+            <a:r>
+              <a:rPr sz="2750" b="0" i="0">
                 <a:solidFill>
                   <a:srgbClr val="1F1F1F"/>
                 </a:solidFill>
@@ -5324,13 +5324,13 @@
         </p:spPr>
         <p:txBody>
           <a:bodyPr wrap="square" lIns="0" rIns="0" tIns="0" bIns="0">
-            <a:normAutofit/>
-          </a:bodyPr>
-          <a:lstStyle/>
-          <a:p>
-            <a:pPr algn="l"/>
-            <a:r>
-              <a:rPr sz="1600" b="0" i="0">
+            <a:noAutofit/>
+          </a:bodyPr>
+          <a:lstStyle/>
+          <a:p>
+            <a:pPr algn="l"/>
+            <a:r>
+              <a:rPr sz="2800" b="0" i="0">
                 <a:solidFill>
                   <a:srgbClr val="1F1F1F"/>
                 </a:solidFill>
@@ -5358,13 +5358,13 @@
         </p:spPr>
         <p:txBody>
           <a:bodyPr wrap="square" lIns="0" rIns="0" tIns="0" bIns="0">
-            <a:normAutofit/>
-          </a:bodyPr>
-          <a:lstStyle/>
-          <a:p>
-            <a:pPr algn="l"/>
-            <a:r>
-              <a:rPr sz="1600" b="0" i="0">
+            <a:noAutofit/>
+          </a:bodyPr>
+          <a:lstStyle/>
+          <a:p>
+            <a:pPr algn="l"/>
+            <a:r>
+              <a:rPr sz="2700" b="0" i="0">
                 <a:solidFill>
                   <a:srgbClr val="1F1F1F"/>
                 </a:solidFill>
@@ -5392,13 +5392,13 @@
         </p:spPr>
         <p:txBody>
           <a:bodyPr wrap="square" lIns="0" rIns="0" tIns="0" bIns="0">
-            <a:normAutofit/>
-          </a:bodyPr>
-          <a:lstStyle/>
-          <a:p>
-            <a:pPr algn="l"/>
-            <a:r>
-              <a:rPr sz="1600" b="0" i="0">
+            <a:noAutofit/>
+          </a:bodyPr>
+          <a:lstStyle/>
+          <a:p>
+            <a:pPr algn="l"/>
+            <a:r>
+              <a:rPr sz="2600" b="0" i="0">
                 <a:solidFill>
                   <a:srgbClr val="1F1F1F"/>
                 </a:solidFill>
@@ -5426,13 +5426,13 @@
         </p:spPr>
         <p:txBody>
           <a:bodyPr wrap="square" lIns="0" rIns="0" tIns="0" bIns="0">
-            <a:normAutofit/>
-          </a:bodyPr>
-          <a:lstStyle/>
-          <a:p>
-            <a:pPr algn="l"/>
-            <a:r>
-              <a:rPr sz="1600" b="0" i="0">
+            <a:noAutofit/>
+          </a:bodyPr>
+          <a:lstStyle/>
+          <a:p>
+            <a:pPr algn="l"/>
+            <a:r>
+              <a:rPr sz="2750" b="0" i="0">
                 <a:solidFill>
                   <a:srgbClr val="1F1F1F"/>
                 </a:solidFill>
@@ -5460,13 +5460,13 @@
         </p:spPr>
         <p:txBody>
           <a:bodyPr wrap="square" lIns="0" rIns="0" tIns="0" bIns="0">
-            <a:normAutofit/>
-          </a:bodyPr>
-          <a:lstStyle/>
-          <a:p>
-            <a:pPr algn="l"/>
-            <a:r>
-              <a:rPr sz="1600" b="0" i="0">
+            <a:noAutofit/>
+          </a:bodyPr>
+          <a:lstStyle/>
+          <a:p>
+            <a:pPr algn="l"/>
+            <a:r>
+              <a:rPr sz="2750" b="0" i="0">
                 <a:solidFill>
                   <a:srgbClr val="1F1F1F"/>
                 </a:solidFill>
@@ -5494,13 +5494,13 @@
         </p:spPr>
         <p:txBody>
           <a:bodyPr wrap="square" lIns="0" rIns="0" tIns="0" bIns="0">
-            <a:normAutofit/>
-          </a:bodyPr>
-          <a:lstStyle/>
-          <a:p>
-            <a:pPr algn="l"/>
-            <a:r>
-              <a:rPr sz="1600" b="0" i="0">
+            <a:noAutofit/>
+          </a:bodyPr>
+          <a:lstStyle/>
+          <a:p>
+            <a:pPr algn="l"/>
+            <a:r>
+              <a:rPr sz="2650" b="0" i="0">
                 <a:solidFill>
                   <a:srgbClr val="1F1F1F"/>
                 </a:solidFill>
@@ -5528,13 +5528,13 @@
         </p:spPr>
         <p:txBody>
           <a:bodyPr wrap="square" lIns="0" rIns="0" tIns="0" bIns="0">
-            <a:normAutofit/>
-          </a:bodyPr>
-          <a:lstStyle/>
-          <a:p>
-            <a:pPr algn="l"/>
-            <a:r>
-              <a:rPr sz="1600" b="0" i="0">
+            <a:noAutofit/>
+          </a:bodyPr>
+          <a:lstStyle/>
+          <a:p>
+            <a:pPr algn="l"/>
+            <a:r>
+              <a:rPr sz="2800" b="0" i="0">
                 <a:solidFill>
                   <a:srgbClr val="1F1F1F"/>
                 </a:solidFill>
@@ -5562,13 +5562,13 @@
         </p:spPr>
         <p:txBody>
           <a:bodyPr wrap="square" lIns="0" rIns="0" tIns="0" bIns="0">
-            <a:normAutofit/>
-          </a:bodyPr>
-          <a:lstStyle/>
-          <a:p>
-            <a:pPr algn="l"/>
-            <a:r>
-              <a:rPr sz="1600" b="0" i="0">
+            <a:noAutofit/>
+          </a:bodyPr>
+          <a:lstStyle/>
+          <a:p>
+            <a:pPr algn="l"/>
+            <a:r>
+              <a:rPr sz="2750" b="0" i="0">
                 <a:solidFill>
                   <a:srgbClr val="1F1F1F"/>
                 </a:solidFill>
@@ -5596,13 +5596,13 @@
         </p:spPr>
         <p:txBody>
           <a:bodyPr wrap="square" lIns="0" rIns="0" tIns="0" bIns="0">
-            <a:normAutofit/>
-          </a:bodyPr>
-          <a:lstStyle/>
-          <a:p>
-            <a:pPr algn="l"/>
-            <a:r>
-              <a:rPr sz="1600" b="0" i="0">
+            <a:noAutofit/>
+          </a:bodyPr>
+          <a:lstStyle/>
+          <a:p>
+            <a:pPr algn="l"/>
+            <a:r>
+              <a:rPr sz="2650" b="0" i="0">
                 <a:solidFill>
                   <a:srgbClr val="1F1F1F"/>
                 </a:solidFill>
@@ -5630,13 +5630,13 @@
         </p:spPr>
         <p:txBody>
           <a:bodyPr wrap="square" lIns="0" rIns="0" tIns="0" bIns="0">
-            <a:normAutofit/>
-          </a:bodyPr>
-          <a:lstStyle/>
-          <a:p>
-            <a:pPr algn="l"/>
-            <a:r>
-              <a:rPr sz="1600" b="0" i="0">
+            <a:noAutofit/>
+          </a:bodyPr>
+          <a:lstStyle/>
+          <a:p>
+            <a:pPr algn="l"/>
+            <a:r>
+              <a:rPr sz="2750" b="0" i="0">
                 <a:solidFill>
                   <a:srgbClr val="1F1F1F"/>
                 </a:solidFill>
@@ -5664,13 +5664,13 @@
         </p:spPr>
         <p:txBody>
           <a:bodyPr wrap="square" lIns="0" rIns="0" tIns="0" bIns="0">
-            <a:normAutofit/>
-          </a:bodyPr>
-          <a:lstStyle/>
-          <a:p>
-            <a:pPr algn="l"/>
-            <a:r>
-              <a:rPr sz="1600" b="0" i="0">
+            <a:noAutofit/>
+          </a:bodyPr>
+          <a:lstStyle/>
+          <a:p>
+            <a:pPr algn="l"/>
+            <a:r>
+              <a:rPr sz="2650" b="0" i="0">
                 <a:solidFill>
                   <a:srgbClr val="1F1F1F"/>
                 </a:solidFill>
@@ -5698,13 +5698,13 @@
         </p:spPr>
         <p:txBody>
           <a:bodyPr wrap="square" lIns="0" rIns="0" tIns="0" bIns="0">
-            <a:normAutofit/>
-          </a:bodyPr>
-          <a:lstStyle/>
-          <a:p>
-            <a:pPr algn="l"/>
-            <a:r>
-              <a:rPr sz="1600" b="0" i="0">
+            <a:noAutofit/>
+          </a:bodyPr>
+          <a:lstStyle/>
+          <a:p>
+            <a:pPr algn="l"/>
+            <a:r>
+              <a:rPr sz="2750" b="0" i="0">
                 <a:solidFill>
                   <a:srgbClr val="1F1F1F"/>
                 </a:solidFill>
@@ -5732,13 +5732,13 @@
         </p:spPr>
         <p:txBody>
           <a:bodyPr wrap="square" lIns="0" rIns="0" tIns="0" bIns="0">
-            <a:normAutofit/>
-          </a:bodyPr>
-          <a:lstStyle/>
-          <a:p>
-            <a:pPr algn="l"/>
-            <a:r>
-              <a:rPr sz="1600" b="0" i="0">
+            <a:noAutofit/>
+          </a:bodyPr>
+          <a:lstStyle/>
+          <a:p>
+            <a:pPr algn="l"/>
+            <a:r>
+              <a:rPr sz="2950" b="0" i="0">
                 <a:solidFill>
                   <a:srgbClr val="A5977D"/>
                 </a:solidFill>
@@ -5766,13 +5766,13 @@
         </p:spPr>
         <p:txBody>
           <a:bodyPr wrap="square" lIns="0" rIns="0" tIns="0" bIns="0">
-            <a:normAutofit/>
-          </a:bodyPr>
-          <a:lstStyle/>
-          <a:p>
-            <a:pPr algn="l"/>
-            <a:r>
-              <a:rPr sz="1600" b="0" i="0">
+            <a:noAutofit/>
+          </a:bodyPr>
+          <a:lstStyle/>
+          <a:p>
+            <a:pPr algn="l"/>
+            <a:r>
+              <a:rPr sz="2450" b="0" i="0">
                 <a:solidFill>
                   <a:srgbClr val="BCB8AE"/>
                 </a:solidFill>
@@ -5800,13 +5800,13 @@
         </p:spPr>
         <p:txBody>
           <a:bodyPr wrap="square" lIns="0" rIns="0" tIns="0" bIns="0">
-            <a:normAutofit/>
-          </a:bodyPr>
-          <a:lstStyle/>
-          <a:p>
-            <a:pPr algn="l"/>
-            <a:r>
-              <a:rPr sz="1600" b="0" i="0">
+            <a:noAutofit/>
+          </a:bodyPr>
+          <a:lstStyle/>
+          <a:p>
+            <a:pPr algn="l"/>
+            <a:r>
+              <a:rPr sz="2450" b="0" i="0">
                 <a:solidFill>
                   <a:srgbClr val="B9B5AB"/>
                 </a:solidFill>
@@ -5834,13 +5834,13 @@
         </p:spPr>
         <p:txBody>
           <a:bodyPr wrap="square" lIns="0" rIns="0" tIns="0" bIns="0">
-            <a:normAutofit/>
-          </a:bodyPr>
-          <a:lstStyle/>
-          <a:p>
-            <a:pPr algn="l"/>
-            <a:r>
-              <a:rPr sz="971" b="0" i="0">
+            <a:noAutofit/>
+          </a:bodyPr>
+          <a:lstStyle/>
+          <a:p>
+            <a:pPr algn="l"/>
+            <a:r>
+              <a:rPr sz="1300" b="0" i="0">
                 <a:solidFill>
                   <a:srgbClr val="1F1F1F"/>
                 </a:solidFill>

</xml_diff>